<commit_message>
Fix survival curve labels and show log-rank p-values
Co-authored-by: pbehbood <pbehbood@users.noreply.github.com>
</commit_message>
<xml_diff>
--- a/data/tcga_lung/important_lung_genes/visual_report/TCGA_Lung_Visual_Summary.pptx
+++ b/data/tcga_lung/important_lung_genes/visual_report/TCGA_Lung_Visual_Summary.pptx
@@ -4202,7 +4202,7 @@
         <p:spPr>
           <a:xfrm>
             <a:off x="320040" y="777240"/>
-            <a:ext cx="11521440" cy="4526280"/>
+            <a:ext cx="11521440" cy="4937760"/>
           </a:xfrm>
           <a:prstGeom prst="rect">
             <a:avLst/>
@@ -4279,7 +4279,7 @@
         <p:spPr>
           <a:xfrm>
             <a:off x="320040" y="777240"/>
-            <a:ext cx="11521440" cy="4526280"/>
+            <a:ext cx="11521440" cy="4937760"/>
           </a:xfrm>
           <a:prstGeom prst="rect">
             <a:avLst/>
@@ -4356,7 +4356,7 @@
         <p:spPr>
           <a:xfrm>
             <a:off x="320040" y="777240"/>
-            <a:ext cx="11521440" cy="4526280"/>
+            <a:ext cx="11521440" cy="4937760"/>
           </a:xfrm>
           <a:prstGeom prst="rect">
             <a:avLst/>
@@ -4433,7 +4433,7 @@
         <p:spPr>
           <a:xfrm>
             <a:off x="320040" y="777240"/>
-            <a:ext cx="11521440" cy="4526280"/>
+            <a:ext cx="11521440" cy="4937760"/>
           </a:xfrm>
           <a:prstGeom prst="rect">
             <a:avLst/>
@@ -4510,7 +4510,7 @@
         <p:spPr>
           <a:xfrm>
             <a:off x="320040" y="777240"/>
-            <a:ext cx="11521440" cy="4526280"/>
+            <a:ext cx="11521440" cy="4937760"/>
           </a:xfrm>
           <a:prstGeom prst="rect">
             <a:avLst/>
@@ -4587,7 +4587,7 @@
         <p:spPr>
           <a:xfrm>
             <a:off x="320040" y="777240"/>
-            <a:ext cx="11521440" cy="4526280"/>
+            <a:ext cx="11521440" cy="4937760"/>
           </a:xfrm>
           <a:prstGeom prst="rect">
             <a:avLst/>
@@ -4741,7 +4741,7 @@
         <p:spPr>
           <a:xfrm>
             <a:off x="320040" y="777240"/>
-            <a:ext cx="11521440" cy="4526280"/>
+            <a:ext cx="11521440" cy="4937760"/>
           </a:xfrm>
           <a:prstGeom prst="rect">
             <a:avLst/>
@@ -4818,7 +4818,7 @@
         <p:spPr>
           <a:xfrm>
             <a:off x="320040" y="777240"/>
-            <a:ext cx="11521440" cy="4526280"/>
+            <a:ext cx="11521440" cy="4937760"/>
           </a:xfrm>
           <a:prstGeom prst="rect">
             <a:avLst/>
@@ -4895,7 +4895,7 @@
         <p:spPr>
           <a:xfrm>
             <a:off x="320040" y="777240"/>
-            <a:ext cx="11521440" cy="4526280"/>
+            <a:ext cx="11521440" cy="4937760"/>
           </a:xfrm>
           <a:prstGeom prst="rect">
             <a:avLst/>

</xml_diff>

<commit_message>
Keep only significant Kaplan-Meier survival curves
Co-authored-by: pbehbood <pbehbood@users.noreply.github.com>
</commit_message>
<xml_diff>
--- a/data/tcga_lung/important_lung_genes/visual_report/TCGA_Lung_Visual_Summary.pptx
+++ b/data/tcga_lung/important_lung_genes/visual_report/TCGA_Lung_Visual_Summary.pptx
@@ -35,9 +35,6 @@
     <p:sldId id="283" r:id="rId34"/>
     <p:sldId id="284" r:id="rId35"/>
     <p:sldId id="285" r:id="rId36"/>
-    <p:sldId id="286" r:id="rId37"/>
-    <p:sldId id="287" r:id="rId38"/>
-    <p:sldId id="288" r:id="rId39"/>
   </p:sldIdLst>
   <p:sldSz cx="12191695" cy="6858000" type="screen4x3"/>
   <p:notesSz cx="6858000" cy="9144000"/>
@@ -4127,7 +4124,7 @@
           <a:lstStyle/>
           <a:p>
             <a:r>
-              <a:t>Kaplan-Meier curves (top associations)</a:t>
+              <a:t>Significant Kaplan-Meier curves (p &lt; 0.05)</a:t>
             </a:r>
           </a:p>
         </p:txBody>
@@ -4180,14 +4177,14 @@
               </a:defRPr>
             </a:pPr>
             <a:r>
-              <a:t>Mutation survival km NOTCH2</a:t>
+              <a:t>Mutation km NOTCH2</a:t>
             </a:r>
           </a:p>
         </p:txBody>
       </p:sp>
       <p:pic>
         <p:nvPicPr>
-          <p:cNvPr id="3" name="Picture 2" descr="17_mutation_survival_km_NOTCH2.png"/>
+          <p:cNvPr id="3" name="Picture 2" descr="significant_km_mutation_km_NOTCH2.png"/>
           <p:cNvPicPr>
             <a:picLocks noChangeAspect="1"/>
           </p:cNvPicPr>
@@ -4257,14 +4254,14 @@
               </a:defRPr>
             </a:pPr>
             <a:r>
-              <a:t>Mutation survival km CDKN2A</a:t>
+              <a:t>Mutation km CDKN2A</a:t>
             </a:r>
           </a:p>
         </p:txBody>
       </p:sp>
       <p:pic>
         <p:nvPicPr>
-          <p:cNvPr id="3" name="Picture 2" descr="17_mutation_survival_km_CDKN2A.png"/>
+          <p:cNvPr id="3" name="Picture 2" descr="significant_km_mutation_km_CDKN2A.png"/>
           <p:cNvPicPr>
             <a:picLocks noChangeAspect="1"/>
           </p:cNvPicPr>
@@ -4334,14 +4331,14 @@
               </a:defRPr>
             </a:pPr>
             <a:r>
-              <a:t>Mutation survival km TP53</a:t>
+              <a:t>Rna km FAT1</a:t>
             </a:r>
           </a:p>
         </p:txBody>
       </p:sp>
       <p:pic>
         <p:nvPicPr>
-          <p:cNvPr id="3" name="Picture 2" descr="17_mutation_survival_km_TP53.png"/>
+          <p:cNvPr id="3" name="Picture 2" descr="significant_km_rna_km_FAT1.png"/>
           <p:cNvPicPr>
             <a:picLocks noChangeAspect="1"/>
           </p:cNvPicPr>
@@ -4411,14 +4408,14 @@
               </a:defRPr>
             </a:pPr>
             <a:r>
-              <a:t>Rna survival km FAT1</a:t>
+              <a:t>Rna km SOX2</a:t>
             </a:r>
           </a:p>
         </p:txBody>
       </p:sp>
       <p:pic>
         <p:nvPicPr>
-          <p:cNvPr id="3" name="Picture 2" descr="18_rna_survival_km_FAT1.png"/>
+          <p:cNvPr id="3" name="Picture 2" descr="significant_km_rna_km_SOX2.png"/>
           <p:cNvPicPr>
             <a:picLocks noChangeAspect="1"/>
           </p:cNvPicPr>
@@ -4488,14 +4485,14 @@
               </a:defRPr>
             </a:pPr>
             <a:r>
-              <a:t>Rna survival km SOX2</a:t>
+              <a:t>Rna km PTEN</a:t>
             </a:r>
           </a:p>
         </p:txBody>
       </p:sp>
       <p:pic>
         <p:nvPicPr>
-          <p:cNvPr id="3" name="Picture 2" descr="18_rna_survival_km_SOX2.png"/>
+          <p:cNvPr id="3" name="Picture 2" descr="significant_km_rna_km_PTEN.png"/>
           <p:cNvPicPr>
             <a:picLocks noChangeAspect="1"/>
           </p:cNvPicPr>
@@ -4565,14 +4562,14 @@
               </a:defRPr>
             </a:pPr>
             <a:r>
-              <a:t>Rna survival km PTEN</a:t>
+              <a:t>Protein km Sox2</a:t>
             </a:r>
           </a:p>
         </p:txBody>
       </p:sp>
       <p:pic>
         <p:nvPicPr>
-          <p:cNvPr id="3" name="Picture 2" descr="18_rna_survival_km_PTEN.png"/>
+          <p:cNvPr id="3" name="Picture 2" descr="significant_km_protein_km_Sox2.png"/>
           <p:cNvPicPr>
             <a:picLocks noChangeAspect="1"/>
           </p:cNvPicPr>
@@ -4680,237 +4677,6 @@
 </file>
 
 <file path=ppt/slides/slide30.xml><?xml version="1.0" encoding="utf-8"?>
-<p:sld xmlns:a="http://schemas.openxmlformats.org/drawingml/2006/main" xmlns:p="http://schemas.openxmlformats.org/presentationml/2006/main" xmlns:r="http://schemas.openxmlformats.org/officeDocument/2006/relationships">
-  <p:cSld>
-    <p:spTree>
-      <p:nvGrpSpPr>
-        <p:cNvPr id="1" name=""/>
-        <p:cNvGrpSpPr/>
-        <p:nvPr/>
-      </p:nvGrpSpPr>
-      <p:grpSpPr/>
-      <p:sp>
-        <p:nvSpPr>
-          <p:cNvPr id="2" name="TextBox 1"/>
-          <p:cNvSpPr txBox="1"/>
-          <p:nvPr/>
-        </p:nvSpPr>
-        <p:spPr>
-          <a:xfrm>
-            <a:off x="365760" y="182880"/>
-            <a:ext cx="11430000" cy="548640"/>
-          </a:xfrm>
-          <a:prstGeom prst="rect">
-            <a:avLst/>
-          </a:prstGeom>
-          <a:noFill/>
-        </p:spPr>
-        <p:txBody>
-          <a:bodyPr wrap="none">
-            <a:spAutoFit/>
-          </a:bodyPr>
-          <a:lstStyle/>
-          <a:p>
-            <a:pPr>
-              <a:defRPr sz="2400" b="1">
-                <a:solidFill>
-                  <a:srgbClr val="0F172A"/>
-                </a:solidFill>
-              </a:defRPr>
-            </a:pPr>
-            <a:r>
-              <a:t>Protein survival km Sox2</a:t>
-            </a:r>
-          </a:p>
-        </p:txBody>
-      </p:sp>
-      <p:pic>
-        <p:nvPicPr>
-          <p:cNvPr id="3" name="Picture 2" descr="19_protein_survival_km_Sox2.png"/>
-          <p:cNvPicPr>
-            <a:picLocks noChangeAspect="1"/>
-          </p:cNvPicPr>
-          <p:nvPr/>
-        </p:nvPicPr>
-        <p:blipFill>
-          <a:blip r:embed="rId2"/>
-          <a:stretch>
-            <a:fillRect/>
-          </a:stretch>
-        </p:blipFill>
-        <p:spPr>
-          <a:xfrm>
-            <a:off x="320040" y="777240"/>
-            <a:ext cx="11521440" cy="4937760"/>
-          </a:xfrm>
-          <a:prstGeom prst="rect">
-            <a:avLst/>
-          </a:prstGeom>
-        </p:spPr>
-      </p:pic>
-    </p:spTree>
-  </p:cSld>
-  <p:clrMapOvr>
-    <a:masterClrMapping/>
-  </p:clrMapOvr>
-</p:sld>
-</file>
-
-<file path=ppt/slides/slide31.xml><?xml version="1.0" encoding="utf-8"?>
-<p:sld xmlns:a="http://schemas.openxmlformats.org/drawingml/2006/main" xmlns:p="http://schemas.openxmlformats.org/presentationml/2006/main" xmlns:r="http://schemas.openxmlformats.org/officeDocument/2006/relationships">
-  <p:cSld>
-    <p:spTree>
-      <p:nvGrpSpPr>
-        <p:cNvPr id="1" name=""/>
-        <p:cNvGrpSpPr/>
-        <p:nvPr/>
-      </p:nvGrpSpPr>
-      <p:grpSpPr/>
-      <p:sp>
-        <p:nvSpPr>
-          <p:cNvPr id="2" name="TextBox 1"/>
-          <p:cNvSpPr txBox="1"/>
-          <p:nvPr/>
-        </p:nvSpPr>
-        <p:spPr>
-          <a:xfrm>
-            <a:off x="365760" y="182880"/>
-            <a:ext cx="11430000" cy="548640"/>
-          </a:xfrm>
-          <a:prstGeom prst="rect">
-            <a:avLst/>
-          </a:prstGeom>
-          <a:noFill/>
-        </p:spPr>
-        <p:txBody>
-          <a:bodyPr wrap="none">
-            <a:spAutoFit/>
-          </a:bodyPr>
-          <a:lstStyle/>
-          <a:p>
-            <a:pPr>
-              <a:defRPr sz="2400" b="1">
-                <a:solidFill>
-                  <a:srgbClr val="0F172A"/>
-                </a:solidFill>
-              </a:defRPr>
-            </a:pPr>
-            <a:r>
-              <a:t>Protein survival km BRAF pS445</a:t>
-            </a:r>
-          </a:p>
-        </p:txBody>
-      </p:sp>
-      <p:pic>
-        <p:nvPicPr>
-          <p:cNvPr id="3" name="Picture 2" descr="19_protein_survival_km_BRAF_pS445.png"/>
-          <p:cNvPicPr>
-            <a:picLocks noChangeAspect="1"/>
-          </p:cNvPicPr>
-          <p:nvPr/>
-        </p:nvPicPr>
-        <p:blipFill>
-          <a:blip r:embed="rId2"/>
-          <a:stretch>
-            <a:fillRect/>
-          </a:stretch>
-        </p:blipFill>
-        <p:spPr>
-          <a:xfrm>
-            <a:off x="320040" y="777240"/>
-            <a:ext cx="11521440" cy="4937760"/>
-          </a:xfrm>
-          <a:prstGeom prst="rect">
-            <a:avLst/>
-          </a:prstGeom>
-        </p:spPr>
-      </p:pic>
-    </p:spTree>
-  </p:cSld>
-  <p:clrMapOvr>
-    <a:masterClrMapping/>
-  </p:clrMapOvr>
-</p:sld>
-</file>
-
-<file path=ppt/slides/slide32.xml><?xml version="1.0" encoding="utf-8"?>
-<p:sld xmlns:a="http://schemas.openxmlformats.org/drawingml/2006/main" xmlns:p="http://schemas.openxmlformats.org/presentationml/2006/main" xmlns:r="http://schemas.openxmlformats.org/officeDocument/2006/relationships">
-  <p:cSld>
-    <p:spTree>
-      <p:nvGrpSpPr>
-        <p:cNvPr id="1" name=""/>
-        <p:cNvGrpSpPr/>
-        <p:nvPr/>
-      </p:nvGrpSpPr>
-      <p:grpSpPr/>
-      <p:sp>
-        <p:nvSpPr>
-          <p:cNvPr id="2" name="TextBox 1"/>
-          <p:cNvSpPr txBox="1"/>
-          <p:nvPr/>
-        </p:nvSpPr>
-        <p:spPr>
-          <a:xfrm>
-            <a:off x="365760" y="182880"/>
-            <a:ext cx="11430000" cy="548640"/>
-          </a:xfrm>
-          <a:prstGeom prst="rect">
-            <a:avLst/>
-          </a:prstGeom>
-          <a:noFill/>
-        </p:spPr>
-        <p:txBody>
-          <a:bodyPr wrap="none">
-            <a:spAutoFit/>
-          </a:bodyPr>
-          <a:lstStyle/>
-          <a:p>
-            <a:pPr>
-              <a:defRPr sz="2400" b="1">
-                <a:solidFill>
-                  <a:srgbClr val="0F172A"/>
-                </a:solidFill>
-              </a:defRPr>
-            </a:pPr>
-            <a:r>
-              <a:t>Protein survival km CMET pY1235</a:t>
-            </a:r>
-          </a:p>
-        </p:txBody>
-      </p:sp>
-      <p:pic>
-        <p:nvPicPr>
-          <p:cNvPr id="3" name="Picture 2" descr="19_protein_survival_km_CMET_pY1235.png"/>
-          <p:cNvPicPr>
-            <a:picLocks noChangeAspect="1"/>
-          </p:cNvPicPr>
-          <p:nvPr/>
-        </p:nvPicPr>
-        <p:blipFill>
-          <a:blip r:embed="rId2"/>
-          <a:stretch>
-            <a:fillRect/>
-          </a:stretch>
-        </p:blipFill>
-        <p:spPr>
-          <a:xfrm>
-            <a:off x="320040" y="777240"/>
-            <a:ext cx="11521440" cy="4937760"/>
-          </a:xfrm>
-          <a:prstGeom prst="rect">
-            <a:avLst/>
-          </a:prstGeom>
-        </p:spPr>
-      </p:pic>
-    </p:spTree>
-  </p:cSld>
-  <p:clrMapOvr>
-    <a:masterClrMapping/>
-  </p:clrMapOvr>
-</p:sld>
-</file>
-
-<file path=ppt/slides/slide33.xml><?xml version="1.0" encoding="utf-8"?>
 <p:sld xmlns:a="http://schemas.openxmlformats.org/drawingml/2006/main" xmlns:p="http://schemas.openxmlformats.org/presentationml/2006/main" xmlns:r="http://schemas.openxmlformats.org/officeDocument/2006/relationships">
   <p:cSld>
     <p:spTree>

</xml_diff>

<commit_message>
Add treatment and resistance proxy slides to PowerPoint
Add eight new SVG charts covering treatment field coverage, prior
treatment status, treatment types, therapeutic agents, disease
response, progression/recurrence, treatment outcomes, and resistance
proxies. Regenerate the HTML report, gallery, summary CSV/JSON, and
both PowerPoint decks.

Co-authored-by: pbehbood <pbehbood@users.noreply.github.com>
</commit_message>
<xml_diff>
--- a/data/tcga_lung/important_lung_genes/visual_report/TCGA_Lung_Visual_Summary.pptx
+++ b/data/tcga_lung/important_lung_genes/visual_report/TCGA_Lung_Visual_Summary.pptx
@@ -35,6 +35,15 @@
     <p:sldId id="283" r:id="rId34"/>
     <p:sldId id="284" r:id="rId35"/>
     <p:sldId id="285" r:id="rId36"/>
+    <p:sldId id="286" r:id="rId37"/>
+    <p:sldId id="287" r:id="rId38"/>
+    <p:sldId id="288" r:id="rId39"/>
+    <p:sldId id="289" r:id="rId40"/>
+    <p:sldId id="290" r:id="rId41"/>
+    <p:sldId id="291" r:id="rId42"/>
+    <p:sldId id="292" r:id="rId43"/>
+    <p:sldId id="293" r:id="rId44"/>
+    <p:sldId id="294" r:id="rId45"/>
   </p:sldIdLst>
   <p:sldSz cx="12191695" cy="6858000" type="screen4x3"/>
   <p:notesSz cx="6858000" cy="9144000"/>
@@ -4124,7 +4133,7 @@
           <a:lstStyle/>
           <a:p>
             <a:r>
-              <a:t>Significant Kaplan-Meier curves (p &lt; 0.05)</a:t>
+              <a:t>Treatment history and resistance proxies</a:t>
             </a:r>
           </a:p>
         </p:txBody>
@@ -4177,14 +4186,14 @@
               </a:defRPr>
             </a:pPr>
             <a:r>
-              <a:t>Mutation km NOTCH2</a:t>
+              <a:t>Treatment field coverage</a:t>
             </a:r>
           </a:p>
         </p:txBody>
       </p:sp>
       <p:pic>
         <p:nvPicPr>
-          <p:cNvPr id="3" name="Picture 2" descr="significant_km_mutation_km_NOTCH2.png"/>
+          <p:cNvPr id="3" name="Picture 2" descr="17_treatment_field_coverage.png"/>
           <p:cNvPicPr>
             <a:picLocks noChangeAspect="1"/>
           </p:cNvPicPr>
@@ -4199,7 +4208,7 @@
         <p:spPr>
           <a:xfrm>
             <a:off x="320040" y="777240"/>
-            <a:ext cx="11521440" cy="4937760"/>
+            <a:ext cx="11521440" cy="4882896"/>
           </a:xfrm>
           <a:prstGeom prst="rect">
             <a:avLst/>
@@ -4254,14 +4263,14 @@
               </a:defRPr>
             </a:pPr>
             <a:r>
-              <a:t>Mutation km CDKN2A</a:t>
+              <a:t>Prior treatment status</a:t>
             </a:r>
           </a:p>
         </p:txBody>
       </p:sp>
       <p:pic>
         <p:nvPicPr>
-          <p:cNvPr id="3" name="Picture 2" descr="significant_km_mutation_km_CDKN2A.png"/>
+          <p:cNvPr id="3" name="Picture 2" descr="18_prior_treatment_status.png"/>
           <p:cNvPicPr>
             <a:picLocks noChangeAspect="1"/>
           </p:cNvPicPr>
@@ -4276,7 +4285,7 @@
         <p:spPr>
           <a:xfrm>
             <a:off x="320040" y="777240"/>
-            <a:ext cx="11521440" cy="4937760"/>
+            <a:ext cx="11521440" cy="2551176"/>
           </a:xfrm>
           <a:prstGeom prst="rect">
             <a:avLst/>
@@ -4331,14 +4340,14 @@
               </a:defRPr>
             </a:pPr>
             <a:r>
-              <a:t>Rna km FAT1</a:t>
+              <a:t>Treatment types</a:t>
             </a:r>
           </a:p>
         </p:txBody>
       </p:sp>
       <p:pic>
         <p:nvPicPr>
-          <p:cNvPr id="3" name="Picture 2" descr="significant_km_rna_km_FAT1.png"/>
+          <p:cNvPr id="3" name="Picture 2" descr="19_treatment_types.png"/>
           <p:cNvPicPr>
             <a:picLocks noChangeAspect="1"/>
           </p:cNvPicPr>
@@ -4353,7 +4362,7 @@
         <p:spPr>
           <a:xfrm>
             <a:off x="320040" y="777240"/>
-            <a:ext cx="11521440" cy="4937760"/>
+            <a:ext cx="11521440" cy="6748272"/>
           </a:xfrm>
           <a:prstGeom prst="rect">
             <a:avLst/>
@@ -4408,14 +4417,14 @@
               </a:defRPr>
             </a:pPr>
             <a:r>
-              <a:t>Rna km SOX2</a:t>
+              <a:t>Top therapeutic agents</a:t>
             </a:r>
           </a:p>
         </p:txBody>
       </p:sp>
       <p:pic>
         <p:nvPicPr>
-          <p:cNvPr id="3" name="Picture 2" descr="significant_km_rna_km_SOX2.png"/>
+          <p:cNvPr id="3" name="Picture 2" descr="20_top_therapeutic_agents.png"/>
           <p:cNvPicPr>
             <a:picLocks noChangeAspect="1"/>
           </p:cNvPicPr>
@@ -4430,7 +4439,7 @@
         <p:spPr>
           <a:xfrm>
             <a:off x="320040" y="777240"/>
-            <a:ext cx="11521440" cy="4937760"/>
+            <a:ext cx="11521440" cy="6748272"/>
           </a:xfrm>
           <a:prstGeom prst="rect">
             <a:avLst/>
@@ -4485,14 +4494,14 @@
               </a:defRPr>
             </a:pPr>
             <a:r>
-              <a:t>Rna km PTEN</a:t>
+              <a:t>Disease response</a:t>
             </a:r>
           </a:p>
         </p:txBody>
       </p:sp>
       <p:pic>
         <p:nvPicPr>
-          <p:cNvPr id="3" name="Picture 2" descr="significant_km_rna_km_PTEN.png"/>
+          <p:cNvPr id="3" name="Picture 2" descr="21_disease_response.png"/>
           <p:cNvPicPr>
             <a:picLocks noChangeAspect="1"/>
           </p:cNvPicPr>
@@ -4507,7 +4516,7 @@
         <p:spPr>
           <a:xfrm>
             <a:off x="320040" y="777240"/>
-            <a:ext cx="11521440" cy="4937760"/>
+            <a:ext cx="11521440" cy="3483864"/>
           </a:xfrm>
           <a:prstGeom prst="rect">
             <a:avLst/>
@@ -4562,14 +4571,14 @@
               </a:defRPr>
             </a:pPr>
             <a:r>
-              <a:t>Protein km Sox2</a:t>
+              <a:t>Progression or recurrence</a:t>
             </a:r>
           </a:p>
         </p:txBody>
       </p:sp>
       <p:pic>
         <p:nvPicPr>
-          <p:cNvPr id="3" name="Picture 2" descr="significant_km_protein_km_Sox2.png"/>
+          <p:cNvPr id="3" name="Picture 2" descr="22_progression_or_recurrence.png"/>
           <p:cNvPicPr>
             <a:picLocks noChangeAspect="1"/>
           </p:cNvPicPr>
@@ -4584,7 +4593,7 @@
         <p:spPr>
           <a:xfrm>
             <a:off x="320040" y="777240"/>
-            <a:ext cx="11521440" cy="4937760"/>
+            <a:ext cx="11521440" cy="2084832"/>
           </a:xfrm>
           <a:prstGeom prst="rect">
             <a:avLst/>
@@ -4688,6 +4697,661 @@
       <p:grpSpPr/>
       <p:sp>
         <p:nvSpPr>
+          <p:cNvPr id="2" name="TextBox 1"/>
+          <p:cNvSpPr txBox="1"/>
+          <p:nvPr/>
+        </p:nvSpPr>
+        <p:spPr>
+          <a:xfrm>
+            <a:off x="365760" y="182880"/>
+            <a:ext cx="11430000" cy="548640"/>
+          </a:xfrm>
+          <a:prstGeom prst="rect">
+            <a:avLst/>
+          </a:prstGeom>
+          <a:noFill/>
+        </p:spPr>
+        <p:txBody>
+          <a:bodyPr wrap="none">
+            <a:spAutoFit/>
+          </a:bodyPr>
+          <a:lstStyle/>
+          <a:p>
+            <a:pPr>
+              <a:defRPr sz="2400" b="1">
+                <a:solidFill>
+                  <a:srgbClr val="0F172A"/>
+                </a:solidFill>
+              </a:defRPr>
+            </a:pPr>
+            <a:r>
+              <a:t>Treatment outcomes</a:t>
+            </a:r>
+          </a:p>
+        </p:txBody>
+      </p:sp>
+      <p:pic>
+        <p:nvPicPr>
+          <p:cNvPr id="3" name="Picture 2" descr="23_treatment_outcomes.png"/>
+          <p:cNvPicPr>
+            <a:picLocks noChangeAspect="1"/>
+          </p:cNvPicPr>
+          <p:nvPr/>
+        </p:nvPicPr>
+        <p:blipFill>
+          <a:blip r:embed="rId2"/>
+          <a:stretch>
+            <a:fillRect/>
+          </a:stretch>
+        </p:blipFill>
+        <p:spPr>
+          <a:xfrm>
+            <a:off x="320040" y="777240"/>
+            <a:ext cx="11521440" cy="3483864"/>
+          </a:xfrm>
+          <a:prstGeom prst="rect">
+            <a:avLst/>
+          </a:prstGeom>
+        </p:spPr>
+      </p:pic>
+    </p:spTree>
+  </p:cSld>
+  <p:clrMapOvr>
+    <a:masterClrMapping/>
+  </p:clrMapOvr>
+</p:sld>
+</file>
+
+<file path=ppt/slides/slide31.xml><?xml version="1.0" encoding="utf-8"?>
+<p:sld xmlns:a="http://schemas.openxmlformats.org/drawingml/2006/main" xmlns:p="http://schemas.openxmlformats.org/presentationml/2006/main" xmlns:r="http://schemas.openxmlformats.org/officeDocument/2006/relationships">
+  <p:cSld>
+    <p:spTree>
+      <p:nvGrpSpPr>
+        <p:cNvPr id="1" name=""/>
+        <p:cNvGrpSpPr/>
+        <p:nvPr/>
+      </p:nvGrpSpPr>
+      <p:grpSpPr/>
+      <p:sp>
+        <p:nvSpPr>
+          <p:cNvPr id="2" name="TextBox 1"/>
+          <p:cNvSpPr txBox="1"/>
+          <p:nvPr/>
+        </p:nvSpPr>
+        <p:spPr>
+          <a:xfrm>
+            <a:off x="365760" y="182880"/>
+            <a:ext cx="11430000" cy="548640"/>
+          </a:xfrm>
+          <a:prstGeom prst="rect">
+            <a:avLst/>
+          </a:prstGeom>
+          <a:noFill/>
+        </p:spPr>
+        <p:txBody>
+          <a:bodyPr wrap="none">
+            <a:spAutoFit/>
+          </a:bodyPr>
+          <a:lstStyle/>
+          <a:p>
+            <a:pPr>
+              <a:defRPr sz="2400" b="1">
+                <a:solidFill>
+                  <a:srgbClr val="0F172A"/>
+                </a:solidFill>
+              </a:defRPr>
+            </a:pPr>
+            <a:r>
+              <a:t>Resistance proxies</a:t>
+            </a:r>
+          </a:p>
+        </p:txBody>
+      </p:sp>
+      <p:pic>
+        <p:nvPicPr>
+          <p:cNvPr id="3" name="Picture 2" descr="24_resistance_proxies.png"/>
+          <p:cNvPicPr>
+            <a:picLocks noChangeAspect="1"/>
+          </p:cNvPicPr>
+          <p:nvPr/>
+        </p:nvPicPr>
+        <p:blipFill>
+          <a:blip r:embed="rId2"/>
+          <a:stretch>
+            <a:fillRect/>
+          </a:stretch>
+        </p:blipFill>
+        <p:spPr>
+          <a:xfrm>
+            <a:off x="320040" y="777240"/>
+            <a:ext cx="11521440" cy="2551176"/>
+          </a:xfrm>
+          <a:prstGeom prst="rect">
+            <a:avLst/>
+          </a:prstGeom>
+        </p:spPr>
+      </p:pic>
+    </p:spTree>
+  </p:cSld>
+  <p:clrMapOvr>
+    <a:masterClrMapping/>
+  </p:clrMapOvr>
+</p:sld>
+</file>
+
+<file path=ppt/slides/slide32.xml><?xml version="1.0" encoding="utf-8"?>
+<p:sld xmlns:a="http://schemas.openxmlformats.org/drawingml/2006/main" xmlns:p="http://schemas.openxmlformats.org/presentationml/2006/main" xmlns:r="http://schemas.openxmlformats.org/officeDocument/2006/relationships">
+  <p:cSld>
+    <p:spTree>
+      <p:nvGrpSpPr>
+        <p:cNvPr id="1" name=""/>
+        <p:cNvGrpSpPr/>
+        <p:nvPr/>
+      </p:nvGrpSpPr>
+      <p:grpSpPr/>
+      <p:sp>
+        <p:nvSpPr>
+          <p:cNvPr id="2" name="Title 1"/>
+          <p:cNvSpPr>
+            <a:spLocks noGrp="1"/>
+          </p:cNvSpPr>
+          <p:nvPr>
+            <p:ph type="title"/>
+          </p:nvPr>
+        </p:nvSpPr>
+        <p:spPr/>
+        <p:txBody>
+          <a:bodyPr/>
+          <a:lstStyle/>
+          <a:p>
+            <a:r>
+              <a:t>Significant Kaplan-Meier curves (p &lt; 0.05)</a:t>
+            </a:r>
+          </a:p>
+        </p:txBody>
+      </p:sp>
+    </p:spTree>
+  </p:cSld>
+  <p:clrMapOvr>
+    <a:masterClrMapping/>
+  </p:clrMapOvr>
+</p:sld>
+</file>
+
+<file path=ppt/slides/slide33.xml><?xml version="1.0" encoding="utf-8"?>
+<p:sld xmlns:a="http://schemas.openxmlformats.org/drawingml/2006/main" xmlns:p="http://schemas.openxmlformats.org/presentationml/2006/main" xmlns:r="http://schemas.openxmlformats.org/officeDocument/2006/relationships">
+  <p:cSld>
+    <p:spTree>
+      <p:nvGrpSpPr>
+        <p:cNvPr id="1" name=""/>
+        <p:cNvGrpSpPr/>
+        <p:nvPr/>
+      </p:nvGrpSpPr>
+      <p:grpSpPr/>
+      <p:sp>
+        <p:nvSpPr>
+          <p:cNvPr id="2" name="TextBox 1"/>
+          <p:cNvSpPr txBox="1"/>
+          <p:nvPr/>
+        </p:nvSpPr>
+        <p:spPr>
+          <a:xfrm>
+            <a:off x="365760" y="182880"/>
+            <a:ext cx="11430000" cy="548640"/>
+          </a:xfrm>
+          <a:prstGeom prst="rect">
+            <a:avLst/>
+          </a:prstGeom>
+          <a:noFill/>
+        </p:spPr>
+        <p:txBody>
+          <a:bodyPr wrap="none">
+            <a:spAutoFit/>
+          </a:bodyPr>
+          <a:lstStyle/>
+          <a:p>
+            <a:pPr>
+              <a:defRPr sz="2400" b="1">
+                <a:solidFill>
+                  <a:srgbClr val="0F172A"/>
+                </a:solidFill>
+              </a:defRPr>
+            </a:pPr>
+            <a:r>
+              <a:t>Mutation km NOTCH2</a:t>
+            </a:r>
+          </a:p>
+        </p:txBody>
+      </p:sp>
+      <p:pic>
+        <p:nvPicPr>
+          <p:cNvPr id="3" name="Picture 2" descr="significant_km_mutation_km_NOTCH2.png"/>
+          <p:cNvPicPr>
+            <a:picLocks noChangeAspect="1"/>
+          </p:cNvPicPr>
+          <p:nvPr/>
+        </p:nvPicPr>
+        <p:blipFill>
+          <a:blip r:embed="rId2"/>
+          <a:stretch>
+            <a:fillRect/>
+          </a:stretch>
+        </p:blipFill>
+        <p:spPr>
+          <a:xfrm>
+            <a:off x="320040" y="777240"/>
+            <a:ext cx="11521440" cy="4937760"/>
+          </a:xfrm>
+          <a:prstGeom prst="rect">
+            <a:avLst/>
+          </a:prstGeom>
+        </p:spPr>
+      </p:pic>
+    </p:spTree>
+  </p:cSld>
+  <p:clrMapOvr>
+    <a:masterClrMapping/>
+  </p:clrMapOvr>
+</p:sld>
+</file>
+
+<file path=ppt/slides/slide34.xml><?xml version="1.0" encoding="utf-8"?>
+<p:sld xmlns:a="http://schemas.openxmlformats.org/drawingml/2006/main" xmlns:p="http://schemas.openxmlformats.org/presentationml/2006/main" xmlns:r="http://schemas.openxmlformats.org/officeDocument/2006/relationships">
+  <p:cSld>
+    <p:spTree>
+      <p:nvGrpSpPr>
+        <p:cNvPr id="1" name=""/>
+        <p:cNvGrpSpPr/>
+        <p:nvPr/>
+      </p:nvGrpSpPr>
+      <p:grpSpPr/>
+      <p:sp>
+        <p:nvSpPr>
+          <p:cNvPr id="2" name="TextBox 1"/>
+          <p:cNvSpPr txBox="1"/>
+          <p:nvPr/>
+        </p:nvSpPr>
+        <p:spPr>
+          <a:xfrm>
+            <a:off x="365760" y="182880"/>
+            <a:ext cx="11430000" cy="548640"/>
+          </a:xfrm>
+          <a:prstGeom prst="rect">
+            <a:avLst/>
+          </a:prstGeom>
+          <a:noFill/>
+        </p:spPr>
+        <p:txBody>
+          <a:bodyPr wrap="none">
+            <a:spAutoFit/>
+          </a:bodyPr>
+          <a:lstStyle/>
+          <a:p>
+            <a:pPr>
+              <a:defRPr sz="2400" b="1">
+                <a:solidFill>
+                  <a:srgbClr val="0F172A"/>
+                </a:solidFill>
+              </a:defRPr>
+            </a:pPr>
+            <a:r>
+              <a:t>Mutation km CDKN2A</a:t>
+            </a:r>
+          </a:p>
+        </p:txBody>
+      </p:sp>
+      <p:pic>
+        <p:nvPicPr>
+          <p:cNvPr id="3" name="Picture 2" descr="significant_km_mutation_km_CDKN2A.png"/>
+          <p:cNvPicPr>
+            <a:picLocks noChangeAspect="1"/>
+          </p:cNvPicPr>
+          <p:nvPr/>
+        </p:nvPicPr>
+        <p:blipFill>
+          <a:blip r:embed="rId2"/>
+          <a:stretch>
+            <a:fillRect/>
+          </a:stretch>
+        </p:blipFill>
+        <p:spPr>
+          <a:xfrm>
+            <a:off x="320040" y="777240"/>
+            <a:ext cx="11521440" cy="4937760"/>
+          </a:xfrm>
+          <a:prstGeom prst="rect">
+            <a:avLst/>
+          </a:prstGeom>
+        </p:spPr>
+      </p:pic>
+    </p:spTree>
+  </p:cSld>
+  <p:clrMapOvr>
+    <a:masterClrMapping/>
+  </p:clrMapOvr>
+</p:sld>
+</file>
+
+<file path=ppt/slides/slide35.xml><?xml version="1.0" encoding="utf-8"?>
+<p:sld xmlns:a="http://schemas.openxmlformats.org/drawingml/2006/main" xmlns:p="http://schemas.openxmlformats.org/presentationml/2006/main" xmlns:r="http://schemas.openxmlformats.org/officeDocument/2006/relationships">
+  <p:cSld>
+    <p:spTree>
+      <p:nvGrpSpPr>
+        <p:cNvPr id="1" name=""/>
+        <p:cNvGrpSpPr/>
+        <p:nvPr/>
+      </p:nvGrpSpPr>
+      <p:grpSpPr/>
+      <p:sp>
+        <p:nvSpPr>
+          <p:cNvPr id="2" name="TextBox 1"/>
+          <p:cNvSpPr txBox="1"/>
+          <p:nvPr/>
+        </p:nvSpPr>
+        <p:spPr>
+          <a:xfrm>
+            <a:off x="365760" y="182880"/>
+            <a:ext cx="11430000" cy="548640"/>
+          </a:xfrm>
+          <a:prstGeom prst="rect">
+            <a:avLst/>
+          </a:prstGeom>
+          <a:noFill/>
+        </p:spPr>
+        <p:txBody>
+          <a:bodyPr wrap="none">
+            <a:spAutoFit/>
+          </a:bodyPr>
+          <a:lstStyle/>
+          <a:p>
+            <a:pPr>
+              <a:defRPr sz="2400" b="1">
+                <a:solidFill>
+                  <a:srgbClr val="0F172A"/>
+                </a:solidFill>
+              </a:defRPr>
+            </a:pPr>
+            <a:r>
+              <a:t>Rna km FAT1</a:t>
+            </a:r>
+          </a:p>
+        </p:txBody>
+      </p:sp>
+      <p:pic>
+        <p:nvPicPr>
+          <p:cNvPr id="3" name="Picture 2" descr="significant_km_rna_km_FAT1.png"/>
+          <p:cNvPicPr>
+            <a:picLocks noChangeAspect="1"/>
+          </p:cNvPicPr>
+          <p:nvPr/>
+        </p:nvPicPr>
+        <p:blipFill>
+          <a:blip r:embed="rId2"/>
+          <a:stretch>
+            <a:fillRect/>
+          </a:stretch>
+        </p:blipFill>
+        <p:spPr>
+          <a:xfrm>
+            <a:off x="320040" y="777240"/>
+            <a:ext cx="11521440" cy="4937760"/>
+          </a:xfrm>
+          <a:prstGeom prst="rect">
+            <a:avLst/>
+          </a:prstGeom>
+        </p:spPr>
+      </p:pic>
+    </p:spTree>
+  </p:cSld>
+  <p:clrMapOvr>
+    <a:masterClrMapping/>
+  </p:clrMapOvr>
+</p:sld>
+</file>
+
+<file path=ppt/slides/slide36.xml><?xml version="1.0" encoding="utf-8"?>
+<p:sld xmlns:a="http://schemas.openxmlformats.org/drawingml/2006/main" xmlns:p="http://schemas.openxmlformats.org/presentationml/2006/main" xmlns:r="http://schemas.openxmlformats.org/officeDocument/2006/relationships">
+  <p:cSld>
+    <p:spTree>
+      <p:nvGrpSpPr>
+        <p:cNvPr id="1" name=""/>
+        <p:cNvGrpSpPr/>
+        <p:nvPr/>
+      </p:nvGrpSpPr>
+      <p:grpSpPr/>
+      <p:sp>
+        <p:nvSpPr>
+          <p:cNvPr id="2" name="TextBox 1"/>
+          <p:cNvSpPr txBox="1"/>
+          <p:nvPr/>
+        </p:nvSpPr>
+        <p:spPr>
+          <a:xfrm>
+            <a:off x="365760" y="182880"/>
+            <a:ext cx="11430000" cy="548640"/>
+          </a:xfrm>
+          <a:prstGeom prst="rect">
+            <a:avLst/>
+          </a:prstGeom>
+          <a:noFill/>
+        </p:spPr>
+        <p:txBody>
+          <a:bodyPr wrap="none">
+            <a:spAutoFit/>
+          </a:bodyPr>
+          <a:lstStyle/>
+          <a:p>
+            <a:pPr>
+              <a:defRPr sz="2400" b="1">
+                <a:solidFill>
+                  <a:srgbClr val="0F172A"/>
+                </a:solidFill>
+              </a:defRPr>
+            </a:pPr>
+            <a:r>
+              <a:t>Rna km SOX2</a:t>
+            </a:r>
+          </a:p>
+        </p:txBody>
+      </p:sp>
+      <p:pic>
+        <p:nvPicPr>
+          <p:cNvPr id="3" name="Picture 2" descr="significant_km_rna_km_SOX2.png"/>
+          <p:cNvPicPr>
+            <a:picLocks noChangeAspect="1"/>
+          </p:cNvPicPr>
+          <p:nvPr/>
+        </p:nvPicPr>
+        <p:blipFill>
+          <a:blip r:embed="rId2"/>
+          <a:stretch>
+            <a:fillRect/>
+          </a:stretch>
+        </p:blipFill>
+        <p:spPr>
+          <a:xfrm>
+            <a:off x="320040" y="777240"/>
+            <a:ext cx="11521440" cy="4937760"/>
+          </a:xfrm>
+          <a:prstGeom prst="rect">
+            <a:avLst/>
+          </a:prstGeom>
+        </p:spPr>
+      </p:pic>
+    </p:spTree>
+  </p:cSld>
+  <p:clrMapOvr>
+    <a:masterClrMapping/>
+  </p:clrMapOvr>
+</p:sld>
+</file>
+
+<file path=ppt/slides/slide37.xml><?xml version="1.0" encoding="utf-8"?>
+<p:sld xmlns:a="http://schemas.openxmlformats.org/drawingml/2006/main" xmlns:p="http://schemas.openxmlformats.org/presentationml/2006/main" xmlns:r="http://schemas.openxmlformats.org/officeDocument/2006/relationships">
+  <p:cSld>
+    <p:spTree>
+      <p:nvGrpSpPr>
+        <p:cNvPr id="1" name=""/>
+        <p:cNvGrpSpPr/>
+        <p:nvPr/>
+      </p:nvGrpSpPr>
+      <p:grpSpPr/>
+      <p:sp>
+        <p:nvSpPr>
+          <p:cNvPr id="2" name="TextBox 1"/>
+          <p:cNvSpPr txBox="1"/>
+          <p:nvPr/>
+        </p:nvSpPr>
+        <p:spPr>
+          <a:xfrm>
+            <a:off x="365760" y="182880"/>
+            <a:ext cx="11430000" cy="548640"/>
+          </a:xfrm>
+          <a:prstGeom prst="rect">
+            <a:avLst/>
+          </a:prstGeom>
+          <a:noFill/>
+        </p:spPr>
+        <p:txBody>
+          <a:bodyPr wrap="none">
+            <a:spAutoFit/>
+          </a:bodyPr>
+          <a:lstStyle/>
+          <a:p>
+            <a:pPr>
+              <a:defRPr sz="2400" b="1">
+                <a:solidFill>
+                  <a:srgbClr val="0F172A"/>
+                </a:solidFill>
+              </a:defRPr>
+            </a:pPr>
+            <a:r>
+              <a:t>Rna km PTEN</a:t>
+            </a:r>
+          </a:p>
+        </p:txBody>
+      </p:sp>
+      <p:pic>
+        <p:nvPicPr>
+          <p:cNvPr id="3" name="Picture 2" descr="significant_km_rna_km_PTEN.png"/>
+          <p:cNvPicPr>
+            <a:picLocks noChangeAspect="1"/>
+          </p:cNvPicPr>
+          <p:nvPr/>
+        </p:nvPicPr>
+        <p:blipFill>
+          <a:blip r:embed="rId2"/>
+          <a:stretch>
+            <a:fillRect/>
+          </a:stretch>
+        </p:blipFill>
+        <p:spPr>
+          <a:xfrm>
+            <a:off x="320040" y="777240"/>
+            <a:ext cx="11521440" cy="4937760"/>
+          </a:xfrm>
+          <a:prstGeom prst="rect">
+            <a:avLst/>
+          </a:prstGeom>
+        </p:spPr>
+      </p:pic>
+    </p:spTree>
+  </p:cSld>
+  <p:clrMapOvr>
+    <a:masterClrMapping/>
+  </p:clrMapOvr>
+</p:sld>
+</file>
+
+<file path=ppt/slides/slide38.xml><?xml version="1.0" encoding="utf-8"?>
+<p:sld xmlns:a="http://schemas.openxmlformats.org/drawingml/2006/main" xmlns:p="http://schemas.openxmlformats.org/presentationml/2006/main" xmlns:r="http://schemas.openxmlformats.org/officeDocument/2006/relationships">
+  <p:cSld>
+    <p:spTree>
+      <p:nvGrpSpPr>
+        <p:cNvPr id="1" name=""/>
+        <p:cNvGrpSpPr/>
+        <p:nvPr/>
+      </p:nvGrpSpPr>
+      <p:grpSpPr/>
+      <p:sp>
+        <p:nvSpPr>
+          <p:cNvPr id="2" name="TextBox 1"/>
+          <p:cNvSpPr txBox="1"/>
+          <p:nvPr/>
+        </p:nvSpPr>
+        <p:spPr>
+          <a:xfrm>
+            <a:off x="365760" y="182880"/>
+            <a:ext cx="11430000" cy="548640"/>
+          </a:xfrm>
+          <a:prstGeom prst="rect">
+            <a:avLst/>
+          </a:prstGeom>
+          <a:noFill/>
+        </p:spPr>
+        <p:txBody>
+          <a:bodyPr wrap="none">
+            <a:spAutoFit/>
+          </a:bodyPr>
+          <a:lstStyle/>
+          <a:p>
+            <a:pPr>
+              <a:defRPr sz="2400" b="1">
+                <a:solidFill>
+                  <a:srgbClr val="0F172A"/>
+                </a:solidFill>
+              </a:defRPr>
+            </a:pPr>
+            <a:r>
+              <a:t>Protein km Sox2</a:t>
+            </a:r>
+          </a:p>
+        </p:txBody>
+      </p:sp>
+      <p:pic>
+        <p:nvPicPr>
+          <p:cNvPr id="3" name="Picture 2" descr="significant_km_protein_km_Sox2.png"/>
+          <p:cNvPicPr>
+            <a:picLocks noChangeAspect="1"/>
+          </p:cNvPicPr>
+          <p:nvPr/>
+        </p:nvPicPr>
+        <p:blipFill>
+          <a:blip r:embed="rId2"/>
+          <a:stretch>
+            <a:fillRect/>
+          </a:stretch>
+        </p:blipFill>
+        <p:spPr>
+          <a:xfrm>
+            <a:off x="320040" y="777240"/>
+            <a:ext cx="11521440" cy="4937760"/>
+          </a:xfrm>
+          <a:prstGeom prst="rect">
+            <a:avLst/>
+          </a:prstGeom>
+        </p:spPr>
+      </p:pic>
+    </p:spTree>
+  </p:cSld>
+  <p:clrMapOvr>
+    <a:masterClrMapping/>
+  </p:clrMapOvr>
+</p:sld>
+</file>
+
+<file path=ppt/slides/slide39.xml><?xml version="1.0" encoding="utf-8"?>
+<p:sld xmlns:a="http://schemas.openxmlformats.org/drawingml/2006/main" xmlns:p="http://schemas.openxmlformats.org/presentationml/2006/main" xmlns:r="http://schemas.openxmlformats.org/officeDocument/2006/relationships">
+  <p:cSld>
+    <p:spTree>
+      <p:nvGrpSpPr>
+        <p:cNvPr id="1" name=""/>
+        <p:cNvGrpSpPr/>
+        <p:nvPr/>
+      </p:nvGrpSpPr>
+      <p:grpSpPr/>
+      <p:sp>
+        <p:nvSpPr>
           <p:cNvPr id="2" name="Title 1"/>
           <p:cNvSpPr>
             <a:spLocks noGrp="1"/>
@@ -4798,7 +5462,15 @@
               <a:defRPr sz="1600"/>
             </a:pPr>
             <a:r>
-              <a:t>Direct drug-resistance labels are sparse in public TCGA clinical data.</a:t>
+              <a:t>Treatment history is partially available; direct drug-resistance labels are sparse.</a:t>
+            </a:r>
+          </a:p>
+          <a:p>
+            <a:pPr>
+              <a:defRPr sz="1600"/>
+            </a:pPr>
+            <a:r>
+              <a:t>Resistance proxies include progression/recurrence and progressive disease outcomes.</a:t>
             </a:r>
           </a:p>
           <a:p>

</xml_diff>